<commit_message>
docs: remove individual contributions from final presentation
</commit_message>
<xml_diff>
--- a/docs/delivery/Smart_Asset_Tracker_Week_4_Final_Presentation_Updated.pptx
+++ b/docs/delivery/Smart_Asset_Tracker_Week_4_Final_Presentation_Updated.pptx
@@ -5009,7 +5009,7 @@
                 <a:ea typeface="DejaVu Sans"/>
                 <a:cs typeface="DejaVu Sans"/>
               </a:rPr>
-              <a:t>AWS cost estimate, individual contribution summary, final slides and a short project reflection.</a:t>
+              <a:t>AWS cost estimate, final slides and a short project reflection.</a:t>
             </a:r>
           </a:p>
         </p:txBody>
@@ -16809,7 +16809,7 @@
                 <a:ea typeface="DejaVu Serif"/>
                 <a:cs typeface="DejaVu Serif"/>
               </a:rPr>
-              <a:t>Team contributions and lessons learned</a:t>
+              <a:t>Lessons learned</a:t>
             </a:r>
           </a:p>
         </p:txBody>
@@ -16868,7 +16868,243 @@
                 <a:ea typeface="DejaVu Sans"/>
                 <a:cs typeface="DejaVu Sans"/>
               </a:rPr>
-              <a:t>Six team members collaborated through Git-based development, review and documentation</a:t>
+              <a:t>Technical and collaboration lessons from the project</a:t>
+            </a:r>
+          </a:p>
+        </p:txBody>
+      </p:sp>
+      <p:sp>
+        <p:nvSpPr>
+          <p:cNvPr id="19" name="">
+            <a:extLst xmlns:a="http://schemas.openxmlformats.org/drawingml/2006/main">
+              <a:ext uri="{FF2B5EF4-FFF2-40B4-BE49-F238E27FC236}">
+                <a16:creationId xmlns:a16="http://schemas.microsoft.com/office/drawing/2014/main" id="{8BCAF582-8EF3-4936-A0AE-B0A5C7937593}"/>
+              </a:ext>
+            </a:extLst>
+          </p:cNvPr>
+          <p:cNvSpPr>
+            <a:spLocks xmlns:a="http://schemas.openxmlformats.org/drawingml/2006/main" noGrp="1"/>
+          </p:cNvSpPr>
+          <p:nvPr/>
+        </p:nvSpPr>
+        <p:spPr>
+          <a:xfrm xmlns:a="http://schemas.openxmlformats.org/drawingml/2006/main">
+            <a:off x="819150" y="2095500"/>
+            <a:ext cx="10287000" cy="476250"/>
+          </a:xfrm>
+          <a:prstGeom xmlns:a="http://schemas.openxmlformats.org/drawingml/2006/main" prst="rect">
+            <a:avLst/>
+          </a:prstGeom>
+          <a:noFill xmlns:a="http://schemas.openxmlformats.org/drawingml/2006/main"/>
+          <a:ln xmlns:a="http://schemas.openxmlformats.org/drawingml/2006/main" w="0">
+            <a:noFill/>
+            <a:prstDash val="solid"/>
+          </a:ln>
+        </p:spPr>
+        <p:txBody>
+          <a:bodyPr xmlns:a="http://schemas.openxmlformats.org/drawingml/2006/main" anchor="ctr">
+            <a:noAutofit/>
+          </a:bodyPr>
+          <a:lstStyle xmlns:a="http://schemas.openxmlformats.org/drawingml/2006/main"/>
+          <a:p xmlns:a="http://schemas.openxmlformats.org/drawingml/2006/main">
+            <a:pPr algn="l">
+              <a:buNone/>
+              <a:defRPr sz="1350" b="1">
+                <a:solidFill>
+                  <a:srgbClr val="182A3A"/>
+                </a:solidFill>
+                <a:latin typeface="DejaVu Sans"/>
+                <a:ea typeface="DejaVu Sans"/>
+                <a:cs typeface="DejaVu Sans"/>
+              </a:defRPr>
+            </a:pPr>
+            <a:r>
+              <a:rPr sz="1350" b="1">
+                <a:solidFill>
+                  <a:srgbClr val="182A3A"/>
+                </a:solidFill>
+                <a:latin typeface="DejaVu Sans"/>
+                <a:ea typeface="DejaVu Sans"/>
+                <a:cs typeface="DejaVu Sans"/>
+              </a:rPr>
+              <a:t>Technical lessons</a:t>
+            </a:r>
+          </a:p>
+        </p:txBody>
+      </p:sp>
+      <p:sp>
+        <p:nvSpPr>
+          <p:cNvPr id="20" name="">
+            <a:extLst xmlns:a="http://schemas.openxmlformats.org/drawingml/2006/main">
+              <a:ext uri="{FF2B5EF4-FFF2-40B4-BE49-F238E27FC236}">
+                <a16:creationId xmlns:a16="http://schemas.microsoft.com/office/drawing/2014/main" id="{E0A7F7B1-A6BF-4643-B8DA-D57261ABCA8F}"/>
+              </a:ext>
+            </a:extLst>
+          </p:cNvPr>
+          <p:cNvSpPr>
+            <a:spLocks xmlns:a="http://schemas.openxmlformats.org/drawingml/2006/main" noGrp="1"/>
+          </p:cNvSpPr>
+          <p:nvPr/>
+        </p:nvSpPr>
+        <p:spPr>
+          <a:xfrm xmlns:a="http://schemas.openxmlformats.org/drawingml/2006/main">
+            <a:off x="819150" y="2714625"/>
+            <a:ext cx="10287000" cy="857250"/>
+          </a:xfrm>
+          <a:prstGeom xmlns:a="http://schemas.openxmlformats.org/drawingml/2006/main" prst="rect">
+            <a:avLst/>
+          </a:prstGeom>
+          <a:noFill xmlns:a="http://schemas.openxmlformats.org/drawingml/2006/main"/>
+          <a:ln xmlns:a="http://schemas.openxmlformats.org/drawingml/2006/main" w="0">
+            <a:noFill/>
+            <a:prstDash val="solid"/>
+          </a:ln>
+        </p:spPr>
+        <p:txBody>
+          <a:bodyPr xmlns:a="http://schemas.openxmlformats.org/drawingml/2006/main" anchor="t">
+            <a:noAutofit/>
+          </a:bodyPr>
+          <a:lstStyle xmlns:a="http://schemas.openxmlformats.org/drawingml/2006/main"/>
+          <a:p xmlns:a="http://schemas.openxmlformats.org/drawingml/2006/main">
+            <a:pPr algn="l">
+              <a:buNone/>
+              <a:defRPr sz="1800" b="0">
+                <a:solidFill>
+                  <a:srgbClr val="586E82"/>
+                </a:solidFill>
+                <a:latin typeface="DejaVu Sans"/>
+                <a:ea typeface="DejaVu Sans"/>
+                <a:cs typeface="DejaVu Sans"/>
+              </a:defRPr>
+            </a:pPr>
+            <a:r>
+              <a:rPr sz="1800" b="0">
+                <a:solidFill>
+                  <a:srgbClr val="586E82"/>
+                </a:solidFill>
+                <a:latin typeface="DejaVu Sans"/>
+                <a:ea typeface="DejaVu Sans"/>
+                <a:cs typeface="DejaVu Sans"/>
+              </a:rPr>
+              <a:t>Backend permissions and private image access need deployment tests alongside unit tests.</a:t>
+            </a:r>
+          </a:p>
+        </p:txBody>
+      </p:sp>
+      <p:sp>
+        <p:nvSpPr>
+          <p:cNvPr id="22" name="">
+            <a:extLst xmlns:a="http://schemas.openxmlformats.org/drawingml/2006/main">
+              <a:ext uri="{FF2B5EF4-FFF2-40B4-BE49-F238E27FC236}">
+                <a16:creationId xmlns:a16="http://schemas.microsoft.com/office/drawing/2014/main" id="{046B8F7B-D798-44B9-A834-C3457123517A}"/>
+              </a:ext>
+            </a:extLst>
+          </p:cNvPr>
+          <p:cNvSpPr>
+            <a:spLocks xmlns:a="http://schemas.openxmlformats.org/drawingml/2006/main" noGrp="1"/>
+          </p:cNvSpPr>
+          <p:nvPr/>
+        </p:nvSpPr>
+        <p:spPr>
+          <a:xfrm xmlns:a="http://schemas.openxmlformats.org/drawingml/2006/main">
+            <a:off x="819150" y="4048125"/>
+            <a:ext cx="10287000" cy="476250"/>
+          </a:xfrm>
+          <a:prstGeom xmlns:a="http://schemas.openxmlformats.org/drawingml/2006/main" prst="rect">
+            <a:avLst/>
+          </a:prstGeom>
+          <a:noFill xmlns:a="http://schemas.openxmlformats.org/drawingml/2006/main"/>
+          <a:ln xmlns:a="http://schemas.openxmlformats.org/drawingml/2006/main" w="0">
+            <a:noFill/>
+            <a:prstDash val="solid"/>
+          </a:ln>
+        </p:spPr>
+        <p:txBody>
+          <a:bodyPr xmlns:a="http://schemas.openxmlformats.org/drawingml/2006/main" anchor="ctr">
+            <a:noAutofit/>
+          </a:bodyPr>
+          <a:lstStyle xmlns:a="http://schemas.openxmlformats.org/drawingml/2006/main"/>
+          <a:p xmlns:a="http://schemas.openxmlformats.org/drawingml/2006/main">
+            <a:pPr algn="l">
+              <a:buNone/>
+              <a:defRPr sz="1350" b="1">
+                <a:solidFill>
+                  <a:srgbClr val="182A3A"/>
+                </a:solidFill>
+                <a:latin typeface="DejaVu Sans"/>
+                <a:ea typeface="DejaVu Sans"/>
+                <a:cs typeface="DejaVu Sans"/>
+              </a:defRPr>
+            </a:pPr>
+            <a:r>
+              <a:rPr sz="1350" b="1">
+                <a:solidFill>
+                  <a:srgbClr val="182A3A"/>
+                </a:solidFill>
+                <a:latin typeface="DejaVu Sans"/>
+                <a:ea typeface="DejaVu Sans"/>
+                <a:cs typeface="DejaVu Sans"/>
+              </a:rPr>
+              <a:t>Collaboration lessons</a:t>
+            </a:r>
+          </a:p>
+        </p:txBody>
+      </p:sp>
+      <p:sp>
+        <p:nvSpPr>
+          <p:cNvPr id="23" name="">
+            <a:extLst xmlns:a="http://schemas.openxmlformats.org/drawingml/2006/main">
+              <a:ext uri="{FF2B5EF4-FFF2-40B4-BE49-F238E27FC236}">
+                <a16:creationId xmlns:a16="http://schemas.microsoft.com/office/drawing/2014/main" id="{5E215ED2-3507-4287-B921-2B5493FD589E}"/>
+              </a:ext>
+            </a:extLst>
+          </p:cNvPr>
+          <p:cNvSpPr>
+            <a:spLocks xmlns:a="http://schemas.openxmlformats.org/drawingml/2006/main" noGrp="1"/>
+          </p:cNvSpPr>
+          <p:nvPr/>
+        </p:nvSpPr>
+        <p:spPr>
+          <a:xfrm xmlns:a="http://schemas.openxmlformats.org/drawingml/2006/main">
+            <a:off x="819150" y="4667250"/>
+            <a:ext cx="10287000" cy="857250"/>
+          </a:xfrm>
+          <a:prstGeom xmlns:a="http://schemas.openxmlformats.org/drawingml/2006/main" prst="rect">
+            <a:avLst/>
+          </a:prstGeom>
+          <a:noFill xmlns:a="http://schemas.openxmlformats.org/drawingml/2006/main"/>
+          <a:ln xmlns:a="http://schemas.openxmlformats.org/drawingml/2006/main" w="0">
+            <a:noFill/>
+            <a:prstDash val="solid"/>
+          </a:ln>
+        </p:spPr>
+        <p:txBody>
+          <a:bodyPr xmlns:a="http://schemas.openxmlformats.org/drawingml/2006/main" anchor="t">
+            <a:noAutofit/>
+          </a:bodyPr>
+          <a:lstStyle xmlns:a="http://schemas.openxmlformats.org/drawingml/2006/main"/>
+          <a:p xmlns:a="http://schemas.openxmlformats.org/drawingml/2006/main">
+            <a:pPr algn="l">
+              <a:buNone/>
+              <a:defRPr sz="1800" b="0">
+                <a:solidFill>
+                  <a:srgbClr val="586E82"/>
+                </a:solidFill>
+                <a:latin typeface="DejaVu Sans"/>
+                <a:ea typeface="DejaVu Sans"/>
+                <a:cs typeface="DejaVu Sans"/>
+              </a:defRPr>
+            </a:pPr>
+            <a:r>
+              <a:rPr sz="1800" b="0">
+                <a:solidFill>
+                  <a:srgbClr val="586E82"/>
+                </a:solidFill>
+                <a:latin typeface="DejaVu Sans"/>
+                <a:ea typeface="DejaVu Sans"/>
+                <a:cs typeface="DejaVu Sans"/>
+              </a:rPr>
+              <a:t>Small pull requests and clear documentation support integration, review and handover.</a:t>
             </a:r>
           </a:p>
         </p:txBody>
@@ -16903,1186 +17139,6 @@
             <a:prstDash val="solid"/>
           </a:ln>
         </p:spPr>
-      </p:sp>
-      <p:sp>
-        <p:nvSpPr>
-          <p:cNvPr id="4" name="">
-            <a:extLst xmlns:a="http://schemas.openxmlformats.org/drawingml/2006/main">
-              <a:ext uri="{FF2B5EF4-FFF2-40B4-BE49-F238E27FC236}">
-                <a16:creationId xmlns:a16="http://schemas.microsoft.com/office/drawing/2014/main" id="{D5AEF9BB-26A0-4F46-A1D2-F4FB6AEC7C95}"/>
-              </a:ext>
-            </a:extLst>
-          </p:cNvPr>
-          <p:cNvSpPr>
-            <a:spLocks xmlns:a="http://schemas.openxmlformats.org/drawingml/2006/main" noGrp="1"/>
-          </p:cNvSpPr>
-          <p:nvPr/>
-        </p:nvSpPr>
-        <p:spPr>
-          <a:xfrm xmlns:a="http://schemas.openxmlformats.org/drawingml/2006/main">
-            <a:off x="819150" y="1619250"/>
-            <a:ext cx="3143250" cy="361950"/>
-          </a:xfrm>
-          <a:prstGeom xmlns:a="http://schemas.openxmlformats.org/drawingml/2006/main" prst="rect">
-            <a:avLst/>
-          </a:prstGeom>
-          <a:noFill xmlns:a="http://schemas.openxmlformats.org/drawingml/2006/main"/>
-          <a:ln xmlns:a="http://schemas.openxmlformats.org/drawingml/2006/main" w="0">
-            <a:noFill/>
-            <a:prstDash val="solid"/>
-          </a:ln>
-        </p:spPr>
-        <p:txBody>
-          <a:bodyPr xmlns:a="http://schemas.openxmlformats.org/drawingml/2006/main" anchor="ctr">
-            <a:noAutofit/>
-          </a:bodyPr>
-          <a:lstStyle xmlns:a="http://schemas.openxmlformats.org/drawingml/2006/main"/>
-          <a:p xmlns:a="http://schemas.openxmlformats.org/drawingml/2006/main">
-            <a:pPr algn="l">
-              <a:buNone/>
-              <a:defRPr sz="1650" b="1">
-                <a:solidFill>
-                  <a:srgbClr val="2E7D5B"/>
-                </a:solidFill>
-                <a:latin typeface="DejaVu Serif"/>
-                <a:ea typeface="DejaVu Serif"/>
-                <a:cs typeface="DejaVu Serif"/>
-              </a:defRPr>
-            </a:pPr>
-            <a:r>
-              <a:rPr sz="1650" b="1">
-                <a:solidFill>
-                  <a:srgbClr val="2E7D5B"/>
-                </a:solidFill>
-                <a:latin typeface="DejaVu Serif"/>
-                <a:ea typeface="DejaVu Serif"/>
-                <a:cs typeface="DejaVu Serif"/>
-              </a:rPr>
-              <a:t>Ashok Hota</a:t>
-            </a:r>
-          </a:p>
-        </p:txBody>
-      </p:sp>
-      <p:sp>
-        <p:nvSpPr>
-          <p:cNvPr id="5" name="">
-            <a:extLst xmlns:a="http://schemas.openxmlformats.org/drawingml/2006/main">
-              <a:ext uri="{FF2B5EF4-FFF2-40B4-BE49-F238E27FC236}">
-                <a16:creationId xmlns:a16="http://schemas.microsoft.com/office/drawing/2014/main" id="{60D9E694-2F3D-4C58-BF87-B7BEEF5966A8}"/>
-              </a:ext>
-            </a:extLst>
-          </p:cNvPr>
-          <p:cNvSpPr>
-            <a:spLocks xmlns:a="http://schemas.openxmlformats.org/drawingml/2006/main" noGrp="1"/>
-          </p:cNvSpPr>
-          <p:nvPr/>
-        </p:nvSpPr>
-        <p:spPr>
-          <a:xfrm xmlns:a="http://schemas.openxmlformats.org/drawingml/2006/main">
-            <a:off x="4286250" y="1647825"/>
-            <a:ext cx="6858000" cy="361950"/>
-          </a:xfrm>
-          <a:prstGeom xmlns:a="http://schemas.openxmlformats.org/drawingml/2006/main" prst="rect">
-            <a:avLst/>
-          </a:prstGeom>
-          <a:noFill xmlns:a="http://schemas.openxmlformats.org/drawingml/2006/main"/>
-          <a:ln xmlns:a="http://schemas.openxmlformats.org/drawingml/2006/main" w="0">
-            <a:noFill/>
-            <a:prstDash val="solid"/>
-          </a:ln>
-        </p:spPr>
-        <p:txBody>
-          <a:bodyPr xmlns:a="http://schemas.openxmlformats.org/drawingml/2006/main" anchor="t">
-            <a:noAutofit/>
-          </a:bodyPr>
-          <a:lstStyle xmlns:a="http://schemas.openxmlformats.org/drawingml/2006/main"/>
-          <a:p xmlns:a="http://schemas.openxmlformats.org/drawingml/2006/main">
-            <a:pPr algn="l">
-              <a:buNone/>
-              <a:defRPr sz="1200" b="0">
-                <a:solidFill>
-                  <a:srgbClr val="586E82"/>
-                </a:solidFill>
-                <a:latin typeface="DejaVu Sans"/>
-                <a:ea typeface="DejaVu Sans"/>
-                <a:cs typeface="DejaVu Sans"/>
-              </a:defRPr>
-            </a:pPr>
-            <a:r>
-              <a:rPr sz="1200" b="0">
-                <a:solidFill>
-                  <a:srgbClr val="586E82"/>
-                </a:solidFill>
-                <a:latin typeface="DejaVu Sans"/>
-                <a:ea typeface="DejaVu Sans"/>
-                <a:cs typeface="DejaVu Sans"/>
-              </a:rPr>
-              <a:t>Contribution to be confirmed</a:t>
-            </a:r>
-          </a:p>
-        </p:txBody>
-      </p:sp>
-      <p:sp>
-        <p:nvSpPr>
-          <p:cNvPr id="6" name="">
-            <a:extLst xmlns:a="http://schemas.openxmlformats.org/drawingml/2006/main">
-              <a:ext uri="{FF2B5EF4-FFF2-40B4-BE49-F238E27FC236}">
-                <a16:creationId xmlns:a16="http://schemas.microsoft.com/office/drawing/2014/main" id="{D08F34AC-9815-4C1E-B3ED-4BAB29D0A4CF}"/>
-              </a:ext>
-            </a:extLst>
-          </p:cNvPr>
-          <p:cNvSpPr>
-            <a:spLocks xmlns:a="http://schemas.openxmlformats.org/drawingml/2006/main" noGrp="1"/>
-          </p:cNvSpPr>
-          <p:nvPr/>
-        </p:nvSpPr>
-        <p:spPr>
-          <a:xfrm xmlns:a="http://schemas.openxmlformats.org/drawingml/2006/main">
-            <a:off x="819150" y="2085975"/>
-            <a:ext cx="3143250" cy="361950"/>
-          </a:xfrm>
-          <a:prstGeom xmlns:a="http://schemas.openxmlformats.org/drawingml/2006/main" prst="rect">
-            <a:avLst/>
-          </a:prstGeom>
-          <a:noFill xmlns:a="http://schemas.openxmlformats.org/drawingml/2006/main"/>
-          <a:ln xmlns:a="http://schemas.openxmlformats.org/drawingml/2006/main" w="0">
-            <a:noFill/>
-            <a:prstDash val="solid"/>
-          </a:ln>
-        </p:spPr>
-        <p:txBody>
-          <a:bodyPr xmlns:a="http://schemas.openxmlformats.org/drawingml/2006/main" anchor="ctr">
-            <a:noAutofit/>
-          </a:bodyPr>
-          <a:lstStyle xmlns:a="http://schemas.openxmlformats.org/drawingml/2006/main"/>
-          <a:p xmlns:a="http://schemas.openxmlformats.org/drawingml/2006/main">
-            <a:pPr algn="l">
-              <a:buNone/>
-              <a:defRPr sz="1650" b="1">
-                <a:solidFill>
-                  <a:srgbClr val="146C94"/>
-                </a:solidFill>
-                <a:latin typeface="DejaVu Serif"/>
-                <a:ea typeface="DejaVu Serif"/>
-                <a:cs typeface="DejaVu Serif"/>
-              </a:defRPr>
-            </a:pPr>
-            <a:r>
-              <a:rPr sz="1650" b="1">
-                <a:solidFill>
-                  <a:srgbClr val="146C94"/>
-                </a:solidFill>
-                <a:latin typeface="DejaVu Serif"/>
-                <a:ea typeface="DejaVu Serif"/>
-                <a:cs typeface="DejaVu Serif"/>
-              </a:rPr>
-              <a:t>Ema Sena</a:t>
-            </a:r>
-          </a:p>
-        </p:txBody>
-      </p:sp>
-      <p:sp>
-        <p:nvSpPr>
-          <p:cNvPr id="7" name="">
-            <a:extLst xmlns:a="http://schemas.openxmlformats.org/drawingml/2006/main">
-              <a:ext uri="{FF2B5EF4-FFF2-40B4-BE49-F238E27FC236}">
-                <a16:creationId xmlns:a16="http://schemas.microsoft.com/office/drawing/2014/main" id="{BD058715-66FE-4255-91BA-80E2CEB08E7F}"/>
-              </a:ext>
-            </a:extLst>
-          </p:cNvPr>
-          <p:cNvSpPr>
-            <a:spLocks xmlns:a="http://schemas.openxmlformats.org/drawingml/2006/main" noGrp="1"/>
-          </p:cNvSpPr>
-          <p:nvPr/>
-        </p:nvSpPr>
-        <p:spPr>
-          <a:xfrm xmlns:a="http://schemas.openxmlformats.org/drawingml/2006/main">
-            <a:off x="4286250" y="2114550"/>
-            <a:ext cx="6858000" cy="361950"/>
-          </a:xfrm>
-          <a:prstGeom xmlns:a="http://schemas.openxmlformats.org/drawingml/2006/main" prst="rect">
-            <a:avLst/>
-          </a:prstGeom>
-          <a:noFill xmlns:a="http://schemas.openxmlformats.org/drawingml/2006/main"/>
-          <a:ln xmlns:a="http://schemas.openxmlformats.org/drawingml/2006/main" w="0">
-            <a:noFill/>
-            <a:prstDash val="solid"/>
-          </a:ln>
-        </p:spPr>
-        <p:txBody>
-          <a:bodyPr xmlns:a="http://schemas.openxmlformats.org/drawingml/2006/main" anchor="t">
-            <a:noAutofit/>
-          </a:bodyPr>
-          <a:lstStyle xmlns:a="http://schemas.openxmlformats.org/drawingml/2006/main"/>
-          <a:p xmlns:a="http://schemas.openxmlformats.org/drawingml/2006/main">
-            <a:pPr algn="l">
-              <a:buNone/>
-              <a:defRPr sz="1200" b="0">
-                <a:solidFill>
-                  <a:srgbClr val="586E82"/>
-                </a:solidFill>
-                <a:latin typeface="DejaVu Sans"/>
-                <a:ea typeface="DejaVu Sans"/>
-                <a:cs typeface="DejaVu Sans"/>
-              </a:defRPr>
-            </a:pPr>
-            <a:r>
-              <a:rPr sz="1200" b="0">
-                <a:solidFill>
-                  <a:srgbClr val="586E82"/>
-                </a:solidFill>
-                <a:latin typeface="DejaVu Sans"/>
-                <a:ea typeface="DejaVu Sans"/>
-                <a:cs typeface="DejaVu Sans"/>
-              </a:rPr>
-              <a:t>AI photo workflow and Amplify</a:t>
-            </a:r>
-          </a:p>
-        </p:txBody>
-      </p:sp>
-      <p:sp>
-        <p:nvSpPr>
-          <p:cNvPr id="8" name="">
-            <a:extLst xmlns:a="http://schemas.openxmlformats.org/drawingml/2006/main">
-              <a:ext uri="{FF2B5EF4-FFF2-40B4-BE49-F238E27FC236}">
-                <a16:creationId xmlns:a16="http://schemas.microsoft.com/office/drawing/2014/main" id="{2ACE5045-F37F-4CB8-9B44-9103BE408AF6}"/>
-              </a:ext>
-            </a:extLst>
-          </p:cNvPr>
-          <p:cNvSpPr>
-            <a:spLocks xmlns:a="http://schemas.openxmlformats.org/drawingml/2006/main" noGrp="1"/>
-          </p:cNvSpPr>
-          <p:nvPr/>
-        </p:nvSpPr>
-        <p:spPr>
-          <a:xfrm xmlns:a="http://schemas.openxmlformats.org/drawingml/2006/main">
-            <a:off x="819150" y="2552700"/>
-            <a:ext cx="3143250" cy="361950"/>
-          </a:xfrm>
-          <a:prstGeom xmlns:a="http://schemas.openxmlformats.org/drawingml/2006/main" prst="rect">
-            <a:avLst/>
-          </a:prstGeom>
-          <a:noFill xmlns:a="http://schemas.openxmlformats.org/drawingml/2006/main"/>
-          <a:ln xmlns:a="http://schemas.openxmlformats.org/drawingml/2006/main" w="0">
-            <a:noFill/>
-            <a:prstDash val="solid"/>
-          </a:ln>
-        </p:spPr>
-        <p:txBody>
-          <a:bodyPr xmlns:a="http://schemas.openxmlformats.org/drawingml/2006/main" anchor="ctr">
-            <a:noAutofit/>
-          </a:bodyPr>
-          <a:lstStyle xmlns:a="http://schemas.openxmlformats.org/drawingml/2006/main"/>
-          <a:p xmlns:a="http://schemas.openxmlformats.org/drawingml/2006/main">
-            <a:pPr algn="l">
-              <a:buNone/>
-              <a:defRPr sz="1650" b="1">
-                <a:solidFill>
-                  <a:srgbClr val="287F76"/>
-                </a:solidFill>
-                <a:latin typeface="DejaVu Serif"/>
-                <a:ea typeface="DejaVu Serif"/>
-                <a:cs typeface="DejaVu Serif"/>
-              </a:defRPr>
-            </a:pPr>
-            <a:r>
-              <a:rPr sz="1650" b="1">
-                <a:solidFill>
-                  <a:srgbClr val="287F76"/>
-                </a:solidFill>
-                <a:latin typeface="DejaVu Serif"/>
-                <a:ea typeface="DejaVu Serif"/>
-                <a:cs typeface="DejaVu Serif"/>
-              </a:rPr>
-              <a:t>Gergely Pankucsi</a:t>
-            </a:r>
-          </a:p>
-        </p:txBody>
-      </p:sp>
-      <p:sp>
-        <p:nvSpPr>
-          <p:cNvPr id="9" name="">
-            <a:extLst xmlns:a="http://schemas.openxmlformats.org/drawingml/2006/main">
-              <a:ext uri="{FF2B5EF4-FFF2-40B4-BE49-F238E27FC236}">
-                <a16:creationId xmlns:a16="http://schemas.microsoft.com/office/drawing/2014/main" id="{F60F7CBB-E19C-4749-8FAA-C4596F6DB76C}"/>
-              </a:ext>
-            </a:extLst>
-          </p:cNvPr>
-          <p:cNvSpPr>
-            <a:spLocks xmlns:a="http://schemas.openxmlformats.org/drawingml/2006/main" noGrp="1"/>
-          </p:cNvSpPr>
-          <p:nvPr/>
-        </p:nvSpPr>
-        <p:spPr>
-          <a:xfrm xmlns:a="http://schemas.openxmlformats.org/drawingml/2006/main">
-            <a:off x="4286250" y="2581275"/>
-            <a:ext cx="6858000" cy="361950"/>
-          </a:xfrm>
-          <a:prstGeom xmlns:a="http://schemas.openxmlformats.org/drawingml/2006/main" prst="rect">
-            <a:avLst/>
-          </a:prstGeom>
-          <a:noFill xmlns:a="http://schemas.openxmlformats.org/drawingml/2006/main"/>
-          <a:ln xmlns:a="http://schemas.openxmlformats.org/drawingml/2006/main" w="0">
-            <a:noFill/>
-            <a:prstDash val="solid"/>
-          </a:ln>
-        </p:spPr>
-        <p:txBody>
-          <a:bodyPr xmlns:a="http://schemas.openxmlformats.org/drawingml/2006/main" anchor="t">
-            <a:noAutofit/>
-          </a:bodyPr>
-          <a:lstStyle xmlns:a="http://schemas.openxmlformats.org/drawingml/2006/main"/>
-          <a:p xmlns:a="http://schemas.openxmlformats.org/drawingml/2006/main">
-            <a:pPr algn="l">
-              <a:buNone/>
-              <a:defRPr sz="1200" b="0">
-                <a:solidFill>
-                  <a:srgbClr val="586E82"/>
-                </a:solidFill>
-                <a:latin typeface="DejaVu Sans"/>
-                <a:ea typeface="DejaVu Sans"/>
-                <a:cs typeface="DejaVu Sans"/>
-              </a:defRPr>
-            </a:pPr>
-            <a:r>
-              <a:rPr sz="1200" b="0">
-                <a:solidFill>
-                  <a:srgbClr val="586E82"/>
-                </a:solidFill>
-                <a:latin typeface="DejaVu Sans"/>
-                <a:ea typeface="DejaVu Sans"/>
-                <a:cs typeface="DejaVu Sans"/>
-              </a:rPr>
-              <a:t>Contribution to be confirmed</a:t>
-            </a:r>
-          </a:p>
-        </p:txBody>
-      </p:sp>
-      <p:sp>
-        <p:nvSpPr>
-          <p:cNvPr id="10" name="">
-            <a:extLst xmlns:a="http://schemas.openxmlformats.org/drawingml/2006/main">
-              <a:ext uri="{FF2B5EF4-FFF2-40B4-BE49-F238E27FC236}">
-                <a16:creationId xmlns:a16="http://schemas.microsoft.com/office/drawing/2014/main" id="{1BD946C6-C53C-4D0D-AAD8-B87EA733FAC3}"/>
-              </a:ext>
-            </a:extLst>
-          </p:cNvPr>
-          <p:cNvSpPr>
-            <a:spLocks xmlns:a="http://schemas.openxmlformats.org/drawingml/2006/main" noGrp="1"/>
-          </p:cNvSpPr>
-          <p:nvPr/>
-        </p:nvSpPr>
-        <p:spPr>
-          <a:xfrm xmlns:a="http://schemas.openxmlformats.org/drawingml/2006/main">
-            <a:off x="819150" y="3019425"/>
-            <a:ext cx="3143250" cy="361950"/>
-          </a:xfrm>
-          <a:prstGeom xmlns:a="http://schemas.openxmlformats.org/drawingml/2006/main" prst="rect">
-            <a:avLst/>
-          </a:prstGeom>
-          <a:noFill xmlns:a="http://schemas.openxmlformats.org/drawingml/2006/main"/>
-          <a:ln xmlns:a="http://schemas.openxmlformats.org/drawingml/2006/main" w="0">
-            <a:noFill/>
-            <a:prstDash val="solid"/>
-          </a:ln>
-        </p:spPr>
-        <p:txBody>
-          <a:bodyPr xmlns:a="http://schemas.openxmlformats.org/drawingml/2006/main" anchor="ctr">
-            <a:noAutofit/>
-          </a:bodyPr>
-          <a:lstStyle xmlns:a="http://schemas.openxmlformats.org/drawingml/2006/main"/>
-          <a:p xmlns:a="http://schemas.openxmlformats.org/drawingml/2006/main">
-            <a:pPr algn="l">
-              <a:buNone/>
-              <a:defRPr sz="1650" b="1">
-                <a:solidFill>
-                  <a:srgbClr val="A66717"/>
-                </a:solidFill>
-                <a:latin typeface="DejaVu Serif"/>
-                <a:ea typeface="DejaVu Serif"/>
-                <a:cs typeface="DejaVu Serif"/>
-              </a:defRPr>
-            </a:pPr>
-            <a:r>
-              <a:rPr sz="1650" b="1">
-                <a:solidFill>
-                  <a:srgbClr val="A66717"/>
-                </a:solidFill>
-                <a:latin typeface="DejaVu Serif"/>
-                <a:ea typeface="DejaVu Serif"/>
-                <a:cs typeface="DejaVu Serif"/>
-              </a:rPr>
-              <a:t>Giovanni Pellizzoni</a:t>
-            </a:r>
-          </a:p>
-        </p:txBody>
-      </p:sp>
-      <p:sp>
-        <p:nvSpPr>
-          <p:cNvPr id="11" name="">
-            <a:extLst xmlns:a="http://schemas.openxmlformats.org/drawingml/2006/main">
-              <a:ext uri="{FF2B5EF4-FFF2-40B4-BE49-F238E27FC236}">
-                <a16:creationId xmlns:a16="http://schemas.microsoft.com/office/drawing/2014/main" id="{6EA3E827-D876-442A-88A8-D06D8A4B0F5F}"/>
-              </a:ext>
-            </a:extLst>
-          </p:cNvPr>
-          <p:cNvSpPr>
-            <a:spLocks xmlns:a="http://schemas.openxmlformats.org/drawingml/2006/main" noGrp="1"/>
-          </p:cNvSpPr>
-          <p:nvPr/>
-        </p:nvSpPr>
-        <p:spPr>
-          <a:xfrm xmlns:a="http://schemas.openxmlformats.org/drawingml/2006/main">
-            <a:off x="4286250" y="3048000"/>
-            <a:ext cx="6858000" cy="361950"/>
-          </a:xfrm>
-          <a:prstGeom xmlns:a="http://schemas.openxmlformats.org/drawingml/2006/main" prst="rect">
-            <a:avLst/>
-          </a:prstGeom>
-          <a:noFill xmlns:a="http://schemas.openxmlformats.org/drawingml/2006/main"/>
-          <a:ln xmlns:a="http://schemas.openxmlformats.org/drawingml/2006/main" w="0">
-            <a:noFill/>
-            <a:prstDash val="solid"/>
-          </a:ln>
-        </p:spPr>
-        <p:txBody>
-          <a:bodyPr xmlns:a="http://schemas.openxmlformats.org/drawingml/2006/main" anchor="t">
-            <a:noAutofit/>
-          </a:bodyPr>
-          <a:lstStyle xmlns:a="http://schemas.openxmlformats.org/drawingml/2006/main"/>
-          <a:p xmlns:a="http://schemas.openxmlformats.org/drawingml/2006/main">
-            <a:pPr algn="l">
-              <a:buNone/>
-              <a:defRPr sz="1200" b="0">
-                <a:solidFill>
-                  <a:srgbClr val="586E82"/>
-                </a:solidFill>
-                <a:latin typeface="DejaVu Sans"/>
-                <a:ea typeface="DejaVu Sans"/>
-                <a:cs typeface="DejaVu Sans"/>
-              </a:defRPr>
-            </a:pPr>
-            <a:r>
-              <a:rPr sz="1200" b="0">
-                <a:solidFill>
-                  <a:srgbClr val="586E82"/>
-                </a:solidFill>
-                <a:latin typeface="DejaVu Sans"/>
-                <a:ea typeface="DejaVu Sans"/>
-                <a:cs typeface="DejaVu Sans"/>
-              </a:rPr>
-              <a:t>Backend and infrastructure updates</a:t>
-            </a:r>
-          </a:p>
-        </p:txBody>
-      </p:sp>
-      <p:sp>
-        <p:nvSpPr>
-          <p:cNvPr id="12" name="">
-            <a:extLst xmlns:a="http://schemas.openxmlformats.org/drawingml/2006/main">
-              <a:ext uri="{FF2B5EF4-FFF2-40B4-BE49-F238E27FC236}">
-                <a16:creationId xmlns:a16="http://schemas.microsoft.com/office/drawing/2014/main" id="{53F56DF7-B41E-4A6C-B7D8-CC0D206EF4EF}"/>
-              </a:ext>
-            </a:extLst>
-          </p:cNvPr>
-          <p:cNvSpPr>
-            <a:spLocks xmlns:a="http://schemas.openxmlformats.org/drawingml/2006/main" noGrp="1"/>
-          </p:cNvSpPr>
-          <p:nvPr/>
-        </p:nvSpPr>
-        <p:spPr>
-          <a:xfrm xmlns:a="http://schemas.openxmlformats.org/drawingml/2006/main">
-            <a:off x="800100" y="3333750"/>
-            <a:ext cx="571500" cy="400050"/>
-          </a:xfrm>
-          <a:prstGeom xmlns:a="http://schemas.openxmlformats.org/drawingml/2006/main" prst="rect">
-            <a:avLst/>
-          </a:prstGeom>
-          <a:noFill xmlns:a="http://schemas.openxmlformats.org/drawingml/2006/main"/>
-          <a:ln xmlns:a="http://schemas.openxmlformats.org/drawingml/2006/main" w="0">
-            <a:noFill/>
-            <a:prstDash val="solid"/>
-          </a:ln>
-        </p:spPr>
-        <p:txBody>
-          <a:bodyPr xmlns:a="http://schemas.openxmlformats.org/drawingml/2006/main" anchor="ctr">
-            <a:noAutofit/>
-          </a:bodyPr>
-          <a:lstStyle xmlns:a="http://schemas.openxmlformats.org/drawingml/2006/main"/>
-          <a:p xmlns:a="http://schemas.openxmlformats.org/drawingml/2006/main">
-            <a:pPr algn="l">
-              <a:buNone/>
-              <a:defRPr sz="1275" b="1">
-                <a:solidFill>
-                  <a:srgbClr val="2E7D5B"/>
-                </a:solidFill>
-                <a:latin typeface="DejaVu Serif"/>
-                <a:ea typeface="DejaVu Serif"/>
-                <a:cs typeface="DejaVu Serif"/>
-              </a:defRPr>
-            </a:pPr>
-            <a:r>
-              <a:rPr sz="1275" b="1">
-                <a:solidFill>
-                  <a:srgbClr val="2E7D5B"/>
-                </a:solidFill>
-                <a:latin typeface="DejaVu Serif"/>
-                <a:ea typeface="DejaVu Serif"/>
-                <a:cs typeface="DejaVu Serif"/>
-              </a:rPr>
-              <a:t/>
-            </a:r>
-          </a:p>
-        </p:txBody>
-      </p:sp>
-      <p:sp>
-        <p:nvSpPr>
-          <p:cNvPr id="13" name="">
-            <a:extLst xmlns:a="http://schemas.openxmlformats.org/drawingml/2006/main">
-              <a:ext uri="{FF2B5EF4-FFF2-40B4-BE49-F238E27FC236}">
-                <a16:creationId xmlns:a16="http://schemas.microsoft.com/office/drawing/2014/main" id="{CF5FEE70-C08B-444A-BCE1-2EB0B9BC8EE9}"/>
-              </a:ext>
-            </a:extLst>
-          </p:cNvPr>
-          <p:cNvSpPr>
-            <a:spLocks xmlns:a="http://schemas.openxmlformats.org/drawingml/2006/main" noGrp="1"/>
-          </p:cNvSpPr>
-          <p:nvPr/>
-        </p:nvSpPr>
-        <p:spPr>
-          <a:xfrm xmlns:a="http://schemas.openxmlformats.org/drawingml/2006/main">
-            <a:off x="819150" y="3486150"/>
-            <a:ext cx="3143250" cy="361950"/>
-          </a:xfrm>
-          <a:prstGeom xmlns:a="http://schemas.openxmlformats.org/drawingml/2006/main" prst="rect">
-            <a:avLst/>
-          </a:prstGeom>
-          <a:noFill xmlns:a="http://schemas.openxmlformats.org/drawingml/2006/main"/>
-          <a:ln xmlns:a="http://schemas.openxmlformats.org/drawingml/2006/main" w="0">
-            <a:noFill/>
-            <a:prstDash val="solid"/>
-          </a:ln>
-        </p:spPr>
-        <p:txBody>
-          <a:bodyPr xmlns:a="http://schemas.openxmlformats.org/drawingml/2006/main" anchor="ctr">
-            <a:noAutofit/>
-          </a:bodyPr>
-          <a:lstStyle xmlns:a="http://schemas.openxmlformats.org/drawingml/2006/main"/>
-          <a:p xmlns:a="http://schemas.openxmlformats.org/drawingml/2006/main">
-            <a:pPr algn="l">
-              <a:buNone/>
-              <a:defRPr sz="1650" b="1">
-                <a:solidFill>
-                  <a:srgbClr val="182A3A"/>
-                </a:solidFill>
-                <a:latin typeface="DejaVu Serif"/>
-                <a:ea typeface="DejaVu Serif"/>
-                <a:cs typeface="DejaVu Serif"/>
-              </a:defRPr>
-            </a:pPr>
-            <a:r>
-              <a:rPr sz="1650" b="1">
-                <a:solidFill>
-                  <a:srgbClr val="182A3A"/>
-                </a:solidFill>
-                <a:latin typeface="DejaVu Serif"/>
-                <a:ea typeface="DejaVu Serif"/>
-                <a:cs typeface="DejaVu Serif"/>
-              </a:rPr>
-              <a:t>Richard Asamoah</a:t>
-            </a:r>
-          </a:p>
-        </p:txBody>
-      </p:sp>
-      <p:sp>
-        <p:nvSpPr>
-          <p:cNvPr id="14" name="">
-            <a:extLst xmlns:a="http://schemas.openxmlformats.org/drawingml/2006/main">
-              <a:ext uri="{FF2B5EF4-FFF2-40B4-BE49-F238E27FC236}">
-                <a16:creationId xmlns:a16="http://schemas.microsoft.com/office/drawing/2014/main" id="{E4C15F42-63D5-4D90-AC59-D4D1237A92ED}"/>
-              </a:ext>
-            </a:extLst>
-          </p:cNvPr>
-          <p:cNvSpPr>
-            <a:spLocks xmlns:a="http://schemas.openxmlformats.org/drawingml/2006/main" noGrp="1"/>
-          </p:cNvSpPr>
-          <p:nvPr/>
-        </p:nvSpPr>
-        <p:spPr>
-          <a:xfrm xmlns:a="http://schemas.openxmlformats.org/drawingml/2006/main">
-            <a:off x="4286250" y="3514725"/>
-            <a:ext cx="6858000" cy="361950"/>
-          </a:xfrm>
-          <a:prstGeom xmlns:a="http://schemas.openxmlformats.org/drawingml/2006/main" prst="rect">
-            <a:avLst/>
-          </a:prstGeom>
-          <a:noFill xmlns:a="http://schemas.openxmlformats.org/drawingml/2006/main"/>
-          <a:ln xmlns:a="http://schemas.openxmlformats.org/drawingml/2006/main" w="0">
-            <a:noFill/>
-            <a:prstDash val="solid"/>
-          </a:ln>
-        </p:spPr>
-        <p:txBody>
-          <a:bodyPr xmlns:a="http://schemas.openxmlformats.org/drawingml/2006/main" anchor="t">
-            <a:noAutofit/>
-          </a:bodyPr>
-          <a:lstStyle xmlns:a="http://schemas.openxmlformats.org/drawingml/2006/main"/>
-          <a:p xmlns:a="http://schemas.openxmlformats.org/drawingml/2006/main">
-            <a:pPr algn="l">
-              <a:buNone/>
-              <a:defRPr sz="1200" b="0">
-                <a:solidFill>
-                  <a:srgbClr val="586E82"/>
-                </a:solidFill>
-                <a:latin typeface="DejaVu Sans"/>
-                <a:ea typeface="DejaVu Sans"/>
-                <a:cs typeface="DejaVu Sans"/>
-              </a:defRPr>
-            </a:pPr>
-            <a:r>
-              <a:rPr sz="1200" b="0">
-                <a:solidFill>
-                  <a:srgbClr val="586E82"/>
-                </a:solidFill>
-                <a:latin typeface="DejaVu Sans"/>
-                <a:ea typeface="DejaVu Sans"/>
-                <a:cs typeface="DejaVu Sans"/>
-              </a:rPr>
-              <a:t>Contribution to be confirmed</a:t>
-            </a:r>
-          </a:p>
-        </p:txBody>
-      </p:sp>
-      <p:sp>
-        <p:nvSpPr>
-          <p:cNvPr id="15" name="">
-            <a:extLst xmlns:a="http://schemas.openxmlformats.org/drawingml/2006/main">
-              <a:ext uri="{FF2B5EF4-FFF2-40B4-BE49-F238E27FC236}">
-                <a16:creationId xmlns:a16="http://schemas.microsoft.com/office/drawing/2014/main" id="{97897294-EA67-4DB8-9AEF-2EB1B4208ADB}"/>
-              </a:ext>
-            </a:extLst>
-          </p:cNvPr>
-          <p:cNvSpPr>
-            <a:spLocks xmlns:a="http://schemas.openxmlformats.org/drawingml/2006/main" noGrp="1"/>
-          </p:cNvSpPr>
-          <p:nvPr/>
-        </p:nvSpPr>
-        <p:spPr>
-          <a:xfrm xmlns:a="http://schemas.openxmlformats.org/drawingml/2006/main">
-            <a:off x="800100" y="4524375"/>
-            <a:ext cx="571500" cy="400050"/>
-          </a:xfrm>
-          <a:prstGeom xmlns:a="http://schemas.openxmlformats.org/drawingml/2006/main" prst="rect">
-            <a:avLst/>
-          </a:prstGeom>
-          <a:noFill xmlns:a="http://schemas.openxmlformats.org/drawingml/2006/main"/>
-          <a:ln xmlns:a="http://schemas.openxmlformats.org/drawingml/2006/main" w="0">
-            <a:noFill/>
-            <a:prstDash val="solid"/>
-          </a:ln>
-        </p:spPr>
-        <p:txBody>
-          <a:bodyPr xmlns:a="http://schemas.openxmlformats.org/drawingml/2006/main" anchor="ctr">
-            <a:noAutofit/>
-          </a:bodyPr>
-          <a:lstStyle xmlns:a="http://schemas.openxmlformats.org/drawingml/2006/main"/>
-          <a:p xmlns:a="http://schemas.openxmlformats.org/drawingml/2006/main">
-            <a:pPr algn="l">
-              <a:buNone/>
-              <a:defRPr sz="1275" b="1">
-                <a:solidFill>
-                  <a:srgbClr val="146C94"/>
-                </a:solidFill>
-                <a:latin typeface="DejaVu Serif"/>
-                <a:ea typeface="DejaVu Serif"/>
-                <a:cs typeface="DejaVu Serif"/>
-              </a:defRPr>
-            </a:pPr>
-            <a:r>
-              <a:rPr sz="1275" b="1">
-                <a:solidFill>
-                  <a:srgbClr val="146C94"/>
-                </a:solidFill>
-                <a:latin typeface="DejaVu Serif"/>
-                <a:ea typeface="DejaVu Serif"/>
-                <a:cs typeface="DejaVu Serif"/>
-              </a:rPr>
-              <a:t/>
-            </a:r>
-          </a:p>
-        </p:txBody>
-      </p:sp>
-      <p:sp>
-        <p:nvSpPr>
-          <p:cNvPr id="16" name="">
-            <a:extLst xmlns:a="http://schemas.openxmlformats.org/drawingml/2006/main">
-              <a:ext uri="{FF2B5EF4-FFF2-40B4-BE49-F238E27FC236}">
-                <a16:creationId xmlns:a16="http://schemas.microsoft.com/office/drawing/2014/main" id="{9651EFC7-B379-4EE6-A4FF-5EC92A14BF8D}"/>
-              </a:ext>
-            </a:extLst>
-          </p:cNvPr>
-          <p:cNvSpPr>
-            <a:spLocks xmlns:a="http://schemas.openxmlformats.org/drawingml/2006/main" noGrp="1"/>
-          </p:cNvSpPr>
-          <p:nvPr/>
-        </p:nvSpPr>
-        <p:spPr>
-          <a:xfrm xmlns:a="http://schemas.openxmlformats.org/drawingml/2006/main">
-            <a:off x="819150" y="3952875"/>
-            <a:ext cx="3143250" cy="361950"/>
-          </a:xfrm>
-          <a:prstGeom xmlns:a="http://schemas.openxmlformats.org/drawingml/2006/main" prst="rect">
-            <a:avLst/>
-          </a:prstGeom>
-          <a:noFill xmlns:a="http://schemas.openxmlformats.org/drawingml/2006/main"/>
-          <a:ln xmlns:a="http://schemas.openxmlformats.org/drawingml/2006/main" w="0">
-            <a:noFill/>
-            <a:prstDash val="solid"/>
-          </a:ln>
-        </p:spPr>
-        <p:txBody>
-          <a:bodyPr xmlns:a="http://schemas.openxmlformats.org/drawingml/2006/main" anchor="ctr">
-            <a:noAutofit/>
-          </a:bodyPr>
-          <a:lstStyle xmlns:a="http://schemas.openxmlformats.org/drawingml/2006/main"/>
-          <a:p xmlns:a="http://schemas.openxmlformats.org/drawingml/2006/main">
-            <a:pPr algn="l">
-              <a:buNone/>
-              <a:defRPr sz="1650" b="1">
-                <a:solidFill>
-                  <a:srgbClr val="182A3A"/>
-                </a:solidFill>
-                <a:latin typeface="DejaVu Serif"/>
-                <a:ea typeface="DejaVu Serif"/>
-                <a:cs typeface="DejaVu Serif"/>
-              </a:defRPr>
-            </a:pPr>
-            <a:r>
-              <a:rPr sz="1650" b="1">
-                <a:solidFill>
-                  <a:srgbClr val="182A3A"/>
-                </a:solidFill>
-                <a:latin typeface="DejaVu Serif"/>
-                <a:ea typeface="DejaVu Serif"/>
-                <a:cs typeface="DejaVu Serif"/>
-              </a:rPr>
-              <a:t>Mladen Mrkić</a:t>
-            </a:r>
-          </a:p>
-        </p:txBody>
-      </p:sp>
-      <p:sp>
-        <p:nvSpPr>
-          <p:cNvPr id="17" name="">
-            <a:extLst xmlns:a="http://schemas.openxmlformats.org/drawingml/2006/main">
-              <a:ext uri="{FF2B5EF4-FFF2-40B4-BE49-F238E27FC236}">
-                <a16:creationId xmlns:a16="http://schemas.microsoft.com/office/drawing/2014/main" id="{C656C5FE-6598-4848-9BDE-1FA2A9BB670D}"/>
-              </a:ext>
-            </a:extLst>
-          </p:cNvPr>
-          <p:cNvSpPr>
-            <a:spLocks xmlns:a="http://schemas.openxmlformats.org/drawingml/2006/main" noGrp="1"/>
-          </p:cNvSpPr>
-          <p:nvPr/>
-        </p:nvSpPr>
-        <p:spPr>
-          <a:xfrm xmlns:a="http://schemas.openxmlformats.org/drawingml/2006/main">
-            <a:off x="4286250" y="3981450"/>
-            <a:ext cx="6858000" cy="361950"/>
-          </a:xfrm>
-          <a:prstGeom xmlns:a="http://schemas.openxmlformats.org/drawingml/2006/main" prst="rect">
-            <a:avLst/>
-          </a:prstGeom>
-          <a:noFill xmlns:a="http://schemas.openxmlformats.org/drawingml/2006/main"/>
-          <a:ln xmlns:a="http://schemas.openxmlformats.org/drawingml/2006/main" w="0">
-            <a:noFill/>
-            <a:prstDash val="solid"/>
-          </a:ln>
-        </p:spPr>
-        <p:txBody>
-          <a:bodyPr xmlns:a="http://schemas.openxmlformats.org/drawingml/2006/main" anchor="t">
-            <a:noAutofit/>
-          </a:bodyPr>
-          <a:lstStyle xmlns:a="http://schemas.openxmlformats.org/drawingml/2006/main"/>
-          <a:p xmlns:a="http://schemas.openxmlformats.org/drawingml/2006/main">
-            <a:pPr algn="l">
-              <a:buNone/>
-              <a:defRPr sz="1200" b="0">
-                <a:solidFill>
-                  <a:srgbClr val="586E82"/>
-                </a:solidFill>
-                <a:latin typeface="DejaVu Sans"/>
-                <a:ea typeface="DejaVu Sans"/>
-                <a:cs typeface="DejaVu Sans"/>
-              </a:defRPr>
-            </a:pPr>
-            <a:r>
-              <a:rPr sz="1200" b="0">
-                <a:solidFill>
-                  <a:srgbClr val="586E82"/>
-                </a:solidFill>
-                <a:latin typeface="DejaVu Sans"/>
-                <a:ea typeface="DejaVu Sans"/>
-                <a:cs typeface="DejaVu Sans"/>
-              </a:rPr>
-              <a:t>AWS cost estimate and peer reviews</a:t>
-            </a:r>
-          </a:p>
-        </p:txBody>
-      </p:sp>
-      <p:sp>
-        <p:nvSpPr>
-          <p:cNvPr id="18" name="">
-            <a:extLst xmlns:a="http://schemas.openxmlformats.org/drawingml/2006/main">
-              <a:ext uri="{FF2B5EF4-FFF2-40B4-BE49-F238E27FC236}">
-                <a16:creationId xmlns:a16="http://schemas.microsoft.com/office/drawing/2014/main" id="{3763A7B7-C21E-44B7-98DD-F228B631E4FF}"/>
-              </a:ext>
-            </a:extLst>
-          </p:cNvPr>
-          <p:cNvSpPr>
-            <a:spLocks xmlns:a="http://schemas.openxmlformats.org/drawingml/2006/main" noGrp="1"/>
-          </p:cNvSpPr>
-          <p:nvPr/>
-        </p:nvSpPr>
-        <p:spPr>
-          <a:xfrm xmlns:a="http://schemas.openxmlformats.org/drawingml/2006/main">
-            <a:off x="6381750" y="3333750"/>
-            <a:ext cx="571500" cy="400050"/>
-          </a:xfrm>
-          <a:prstGeom xmlns:a="http://schemas.openxmlformats.org/drawingml/2006/main" prst="rect">
-            <a:avLst/>
-          </a:prstGeom>
-          <a:noFill xmlns:a="http://schemas.openxmlformats.org/drawingml/2006/main"/>
-          <a:ln xmlns:a="http://schemas.openxmlformats.org/drawingml/2006/main" w="0">
-            <a:noFill/>
-            <a:prstDash val="solid"/>
-          </a:ln>
-        </p:spPr>
-        <p:txBody>
-          <a:bodyPr xmlns:a="http://schemas.openxmlformats.org/drawingml/2006/main" anchor="ctr">
-            <a:noAutofit/>
-          </a:bodyPr>
-          <a:lstStyle xmlns:a="http://schemas.openxmlformats.org/drawingml/2006/main"/>
-          <a:p xmlns:a="http://schemas.openxmlformats.org/drawingml/2006/main">
-            <a:pPr algn="l">
-              <a:buNone/>
-              <a:defRPr sz="1275" b="1">
-                <a:solidFill>
-                  <a:srgbClr val="287F76"/>
-                </a:solidFill>
-                <a:latin typeface="DejaVu Serif"/>
-                <a:ea typeface="DejaVu Serif"/>
-                <a:cs typeface="DejaVu Serif"/>
-              </a:defRPr>
-            </a:pPr>
-            <a:r>
-              <a:rPr sz="1275" b="1">
-                <a:solidFill>
-                  <a:srgbClr val="287F76"/>
-                </a:solidFill>
-                <a:latin typeface="DejaVu Serif"/>
-                <a:ea typeface="DejaVu Serif"/>
-                <a:cs typeface="DejaVu Serif"/>
-              </a:rPr>
-              <a:t/>
-            </a:r>
-          </a:p>
-        </p:txBody>
-      </p:sp>
-      <p:sp>
-        <p:nvSpPr>
-          <p:cNvPr id="19" name="">
-            <a:extLst xmlns:a="http://schemas.openxmlformats.org/drawingml/2006/main">
-              <a:ext uri="{FF2B5EF4-FFF2-40B4-BE49-F238E27FC236}">
-                <a16:creationId xmlns:a16="http://schemas.microsoft.com/office/drawing/2014/main" id="{8BCAF582-8EF3-4936-A0AE-B0A5C7937593}"/>
-              </a:ext>
-            </a:extLst>
-          </p:cNvPr>
-          <p:cNvSpPr>
-            <a:spLocks xmlns:a="http://schemas.openxmlformats.org/drawingml/2006/main" noGrp="1"/>
-          </p:cNvSpPr>
-          <p:nvPr/>
-        </p:nvSpPr>
-        <p:spPr>
-          <a:xfrm xmlns:a="http://schemas.openxmlformats.org/drawingml/2006/main">
-            <a:off x="819150" y="4810125"/>
-            <a:ext cx="3143250" cy="476250"/>
-          </a:xfrm>
-          <a:prstGeom xmlns:a="http://schemas.openxmlformats.org/drawingml/2006/main" prst="rect">
-            <a:avLst/>
-          </a:prstGeom>
-          <a:noFill xmlns:a="http://schemas.openxmlformats.org/drawingml/2006/main"/>
-          <a:ln xmlns:a="http://schemas.openxmlformats.org/drawingml/2006/main" w="0">
-            <a:noFill/>
-            <a:prstDash val="solid"/>
-          </a:ln>
-        </p:spPr>
-        <p:txBody>
-          <a:bodyPr xmlns:a="http://schemas.openxmlformats.org/drawingml/2006/main" anchor="ctr">
-            <a:noAutofit/>
-          </a:bodyPr>
-          <a:lstStyle xmlns:a="http://schemas.openxmlformats.org/drawingml/2006/main"/>
-          <a:p xmlns:a="http://schemas.openxmlformats.org/drawingml/2006/main">
-            <a:pPr algn="l">
-              <a:buNone/>
-              <a:defRPr sz="1350" b="1">
-                <a:solidFill>
-                  <a:srgbClr val="182A3A"/>
-                </a:solidFill>
-                <a:latin typeface="DejaVu Sans"/>
-                <a:ea typeface="DejaVu Sans"/>
-                <a:cs typeface="DejaVu Sans"/>
-              </a:defRPr>
-            </a:pPr>
-            <a:r>
-              <a:rPr sz="1350" b="1">
-                <a:solidFill>
-                  <a:srgbClr val="182A3A"/>
-                </a:solidFill>
-                <a:latin typeface="DejaVu Sans"/>
-                <a:ea typeface="DejaVu Sans"/>
-                <a:cs typeface="DejaVu Sans"/>
-              </a:rPr>
-              <a:t>Technical lessons</a:t>
-            </a:r>
-          </a:p>
-        </p:txBody>
-      </p:sp>
-      <p:sp>
-        <p:nvSpPr>
-          <p:cNvPr id="20" name="">
-            <a:extLst xmlns:a="http://schemas.openxmlformats.org/drawingml/2006/main">
-              <a:ext uri="{FF2B5EF4-FFF2-40B4-BE49-F238E27FC236}">
-                <a16:creationId xmlns:a16="http://schemas.microsoft.com/office/drawing/2014/main" id="{E0A7F7B1-A6BF-4643-B8DA-D57261ABCA8F}"/>
-              </a:ext>
-            </a:extLst>
-          </p:cNvPr>
-          <p:cNvSpPr>
-            <a:spLocks xmlns:a="http://schemas.openxmlformats.org/drawingml/2006/main" noGrp="1"/>
-          </p:cNvSpPr>
-          <p:nvPr/>
-        </p:nvSpPr>
-        <p:spPr>
-          <a:xfrm xmlns:a="http://schemas.openxmlformats.org/drawingml/2006/main">
-            <a:off x="4286250" y="4810125"/>
-            <a:ext cx="6858000" cy="571500"/>
-          </a:xfrm>
-          <a:prstGeom xmlns:a="http://schemas.openxmlformats.org/drawingml/2006/main" prst="rect">
-            <a:avLst/>
-          </a:prstGeom>
-          <a:noFill xmlns:a="http://schemas.openxmlformats.org/drawingml/2006/main"/>
-          <a:ln xmlns:a="http://schemas.openxmlformats.org/drawingml/2006/main" w="0">
-            <a:noFill/>
-            <a:prstDash val="solid"/>
-          </a:ln>
-        </p:spPr>
-        <p:txBody>
-          <a:bodyPr xmlns:a="http://schemas.openxmlformats.org/drawingml/2006/main" anchor="t">
-            <a:noAutofit/>
-          </a:bodyPr>
-          <a:lstStyle xmlns:a="http://schemas.openxmlformats.org/drawingml/2006/main"/>
-          <a:p xmlns:a="http://schemas.openxmlformats.org/drawingml/2006/main">
-            <a:pPr algn="l">
-              <a:buNone/>
-              <a:defRPr sz="1050" b="0">
-                <a:solidFill>
-                  <a:srgbClr val="586E82"/>
-                </a:solidFill>
-                <a:latin typeface="DejaVu Sans"/>
-                <a:ea typeface="DejaVu Sans"/>
-                <a:cs typeface="DejaVu Sans"/>
-              </a:defRPr>
-            </a:pPr>
-            <a:r>
-              <a:rPr sz="1050" b="0">
-                <a:solidFill>
-                  <a:srgbClr val="586E82"/>
-                </a:solidFill>
-                <a:latin typeface="DejaVu Sans"/>
-                <a:ea typeface="DejaVu Sans"/>
-                <a:cs typeface="DejaVu Sans"/>
-              </a:rPr>
-              <a:t>Backend permissions and private image access need deployment tests alongside unit tests.</a:t>
-            </a:r>
-          </a:p>
-        </p:txBody>
-      </p:sp>
-      <p:sp>
-        <p:nvSpPr>
-          <p:cNvPr id="21" name="">
-            <a:extLst xmlns:a="http://schemas.openxmlformats.org/drawingml/2006/main">
-              <a:ext uri="{FF2B5EF4-FFF2-40B4-BE49-F238E27FC236}">
-                <a16:creationId xmlns:a16="http://schemas.microsoft.com/office/drawing/2014/main" id="{9F1915DA-56FE-45C6-902C-4257CECC6347}"/>
-              </a:ext>
-            </a:extLst>
-          </p:cNvPr>
-          <p:cNvSpPr>
-            <a:spLocks xmlns:a="http://schemas.openxmlformats.org/drawingml/2006/main" noGrp="1"/>
-          </p:cNvSpPr>
-          <p:nvPr/>
-        </p:nvSpPr>
-        <p:spPr>
-          <a:xfrm xmlns:a="http://schemas.openxmlformats.org/drawingml/2006/main">
-            <a:off x="6381750" y="4524375"/>
-            <a:ext cx="571500" cy="400050"/>
-          </a:xfrm>
-          <a:prstGeom xmlns:a="http://schemas.openxmlformats.org/drawingml/2006/main" prst="rect">
-            <a:avLst/>
-          </a:prstGeom>
-          <a:noFill xmlns:a="http://schemas.openxmlformats.org/drawingml/2006/main"/>
-          <a:ln xmlns:a="http://schemas.openxmlformats.org/drawingml/2006/main" w="0">
-            <a:noFill/>
-            <a:prstDash val="solid"/>
-          </a:ln>
-        </p:spPr>
-        <p:txBody>
-          <a:bodyPr xmlns:a="http://schemas.openxmlformats.org/drawingml/2006/main" anchor="ctr">
-            <a:noAutofit/>
-          </a:bodyPr>
-          <a:lstStyle xmlns:a="http://schemas.openxmlformats.org/drawingml/2006/main"/>
-          <a:p xmlns:a="http://schemas.openxmlformats.org/drawingml/2006/main">
-            <a:pPr algn="l">
-              <a:buNone/>
-              <a:defRPr sz="1275" b="1">
-                <a:solidFill>
-                  <a:srgbClr val="A66717"/>
-                </a:solidFill>
-                <a:latin typeface="DejaVu Serif"/>
-                <a:ea typeface="DejaVu Serif"/>
-                <a:cs typeface="DejaVu Serif"/>
-              </a:defRPr>
-            </a:pPr>
-            <a:r>
-              <a:rPr sz="1275" b="1">
-                <a:solidFill>
-                  <a:srgbClr val="A66717"/>
-                </a:solidFill>
-                <a:latin typeface="DejaVu Serif"/>
-                <a:ea typeface="DejaVu Serif"/>
-                <a:cs typeface="DejaVu Serif"/>
-              </a:rPr>
-              <a:t/>
-            </a:r>
-          </a:p>
-        </p:txBody>
-      </p:sp>
-      <p:sp>
-        <p:nvSpPr>
-          <p:cNvPr id="22" name="">
-            <a:extLst xmlns:a="http://schemas.openxmlformats.org/drawingml/2006/main">
-              <a:ext uri="{FF2B5EF4-FFF2-40B4-BE49-F238E27FC236}">
-                <a16:creationId xmlns:a16="http://schemas.microsoft.com/office/drawing/2014/main" id="{046B8F7B-D798-44B9-A834-C3457123517A}"/>
-              </a:ext>
-            </a:extLst>
-          </p:cNvPr>
-          <p:cNvSpPr>
-            <a:spLocks xmlns:a="http://schemas.openxmlformats.org/drawingml/2006/main" noGrp="1"/>
-          </p:cNvSpPr>
-          <p:nvPr/>
-        </p:nvSpPr>
-        <p:spPr>
-          <a:xfrm xmlns:a="http://schemas.openxmlformats.org/drawingml/2006/main">
-            <a:off x="819150" y="5572125"/>
-            <a:ext cx="3143250" cy="476250"/>
-          </a:xfrm>
-          <a:prstGeom xmlns:a="http://schemas.openxmlformats.org/drawingml/2006/main" prst="rect">
-            <a:avLst/>
-          </a:prstGeom>
-          <a:noFill xmlns:a="http://schemas.openxmlformats.org/drawingml/2006/main"/>
-          <a:ln xmlns:a="http://schemas.openxmlformats.org/drawingml/2006/main" w="0">
-            <a:noFill/>
-            <a:prstDash val="solid"/>
-          </a:ln>
-        </p:spPr>
-        <p:txBody>
-          <a:bodyPr xmlns:a="http://schemas.openxmlformats.org/drawingml/2006/main" anchor="ctr">
-            <a:noAutofit/>
-          </a:bodyPr>
-          <a:lstStyle xmlns:a="http://schemas.openxmlformats.org/drawingml/2006/main"/>
-          <a:p xmlns:a="http://schemas.openxmlformats.org/drawingml/2006/main">
-            <a:pPr algn="l">
-              <a:buNone/>
-              <a:defRPr sz="1350" b="1">
-                <a:solidFill>
-                  <a:srgbClr val="182A3A"/>
-                </a:solidFill>
-                <a:latin typeface="DejaVu Sans"/>
-                <a:ea typeface="DejaVu Sans"/>
-                <a:cs typeface="DejaVu Sans"/>
-              </a:defRPr>
-            </a:pPr>
-            <a:r>
-              <a:rPr sz="1350" b="1">
-                <a:solidFill>
-                  <a:srgbClr val="182A3A"/>
-                </a:solidFill>
-                <a:latin typeface="DejaVu Sans"/>
-                <a:ea typeface="DejaVu Sans"/>
-                <a:cs typeface="DejaVu Sans"/>
-              </a:rPr>
-              <a:t>Collaboration lessons</a:t>
-            </a:r>
-          </a:p>
-        </p:txBody>
-      </p:sp>
-      <p:sp>
-        <p:nvSpPr>
-          <p:cNvPr id="23" name="">
-            <a:extLst xmlns:a="http://schemas.openxmlformats.org/drawingml/2006/main">
-              <a:ext uri="{FF2B5EF4-FFF2-40B4-BE49-F238E27FC236}">
-                <a16:creationId xmlns:a16="http://schemas.microsoft.com/office/drawing/2014/main" id="{5E215ED2-3507-4287-B921-2B5493FD589E}"/>
-              </a:ext>
-            </a:extLst>
-          </p:cNvPr>
-          <p:cNvSpPr>
-            <a:spLocks xmlns:a="http://schemas.openxmlformats.org/drawingml/2006/main" noGrp="1"/>
-          </p:cNvSpPr>
-          <p:nvPr/>
-        </p:nvSpPr>
-        <p:spPr>
-          <a:xfrm xmlns:a="http://schemas.openxmlformats.org/drawingml/2006/main">
-            <a:off x="4286250" y="5572125"/>
-            <a:ext cx="6858000" cy="571500"/>
-          </a:xfrm>
-          <a:prstGeom xmlns:a="http://schemas.openxmlformats.org/drawingml/2006/main" prst="rect">
-            <a:avLst/>
-          </a:prstGeom>
-          <a:noFill xmlns:a="http://schemas.openxmlformats.org/drawingml/2006/main"/>
-          <a:ln xmlns:a="http://schemas.openxmlformats.org/drawingml/2006/main" w="0">
-            <a:noFill/>
-            <a:prstDash val="solid"/>
-          </a:ln>
-        </p:spPr>
-        <p:txBody>
-          <a:bodyPr xmlns:a="http://schemas.openxmlformats.org/drawingml/2006/main" anchor="t">
-            <a:noAutofit/>
-          </a:bodyPr>
-          <a:lstStyle xmlns:a="http://schemas.openxmlformats.org/drawingml/2006/main"/>
-          <a:p xmlns:a="http://schemas.openxmlformats.org/drawingml/2006/main">
-            <a:pPr algn="l">
-              <a:buNone/>
-              <a:defRPr sz="1050" b="0">
-                <a:solidFill>
-                  <a:srgbClr val="586E82"/>
-                </a:solidFill>
-                <a:latin typeface="DejaVu Sans"/>
-                <a:ea typeface="DejaVu Sans"/>
-                <a:cs typeface="DejaVu Sans"/>
-              </a:defRPr>
-            </a:pPr>
-            <a:r>
-              <a:rPr sz="1050" b="0">
-                <a:solidFill>
-                  <a:srgbClr val="586E82"/>
-                </a:solidFill>
-                <a:latin typeface="DejaVu Sans"/>
-                <a:ea typeface="DejaVu Sans"/>
-                <a:cs typeface="DejaVu Sans"/>
-              </a:rPr>
-              <a:t>Small pull requests and clear documentation support integration, review and handover.</a:t>
-            </a:r>
-          </a:p>
-        </p:txBody>
       </p:sp>
       <p:sp>
         <p:nvSpPr>

</xml_diff>